<commit_message>
W04 D2 follows Monday's settled facts: the other 880 drivers at 1.90, Rs 92.7 lakh, Monday's number grouping
Monday's finishing session settled the answer to driver operations on the 880 drivers who were there
before the launch, so Tuesday copies those ids and drops its own 1,020 count. The saving prints
Monday's Rs 92.7 lakh with half or a fifth paired the right way round, case counts take Monday's
grouping, option lists render as lettered lines, S1's ticket table runs full width, the map and tree
nodes are shortened, and the run sheet points at Monday's role cards.

Co-Authored-By: Claude Opus 5.5 <noreply@anthropic.com>
Claude-Session: https://claude.ai/code/session_01USyZ9LfgL4fjeuMBVArE8h
</commit_message>
<xml_diff>
--- a/content/W04/D2/slides/C2_W04_D02_half1_STUDENT.pptx
+++ b/content/W04/D2/slides/C2_W04_D02_half1_STUDENT.pptx
@@ -1802,7 +1802,12 @@
           </a:p>
           <a:p>
             <a:r>
-              <a:t>tables in the facts file: the 1,020 are the 1,200 drivers less the idle tail.</a:t>
+              <a:t>tables in the facts file: the 880 are the 1,200 drivers less the 180 in the idle tail and the 140</a:t>
+            </a:r>
+          </a:p>
+          <a:p>
+            <a:r>
+              <a:t>joiners, and none of the joiners is in the tail.</a:t>
             </a:r>
           </a:p>
           <a:p>
@@ -7965,7 +7970,7 @@
                 </a:solidFill>
                 <a:latin typeface="Calibri"/>
               </a:rPr>
-              <a:t>- a) Peak online hours +24 percent and completed peak trips +3 percent</a:t>
+              <a:t>a) Peak online hours +24 percent and completed peak trips +3 percent</a:t>
             </a:r>
           </a:p>
           <a:p>
@@ -7981,7 +7986,7 @@
                 </a:solidFill>
                 <a:latin typeface="Calibri"/>
               </a:rPr>
-              <a:t>- b) Trips per peak online hour 1.90 to 1.58 and top-up to low acceptance 61 percent</a:t>
+              <a:t>b) Trips per peak online hour 1.90 to 1.58 and top-up to low acceptance 61 percent</a:t>
             </a:r>
           </a:p>
           <a:p>
@@ -7997,7 +8002,7 @@
                 </a:solidFill>
                 <a:latin typeface="Calibri"/>
               </a:rPr>
-              <a:t>- c) Median rider wait 4.8 to 4.6 minutes and new drivers since launch 140</a:t>
+              <a:t>c) Median rider wait 4.8 to 4.6 minutes and new drivers since launch 140</a:t>
             </a:r>
           </a:p>
           <a:p>
@@ -8013,7 +8018,7 @@
                 </a:solidFill>
                 <a:latin typeface="Calibri"/>
               </a:rPr>
-              <a:t>- d) Acceptance share 0.86 to 0.73 and top-up paid Rs 1.9 crore</a:t>
+              <a:t>d) Acceptance share 0.86 to 0.73 and top-up paid Rs 1.9 crore</a:t>
             </a:r>
           </a:p>
           <a:p>
@@ -9905,7 +9910,7 @@
                           </a:solidFill>
                           <a:latin typeface="Calibri"/>
                         </a:rPr>
-                        <a:t>2,51,910</a:t>
+                        <a:t>251,910</a:t>
                       </a:r>
                     </a:p>
                   </a:txBody>
@@ -9927,7 +9932,7 @@
                           </a:solidFill>
                           <a:latin typeface="Calibri"/>
                         </a:rPr>
-                        <a:t>2,56,556</a:t>
+                        <a:t>256,556</a:t>
                       </a:r>
                     </a:p>
                   </a:txBody>
@@ -10844,7 +10849,7 @@
                           </a:solidFill>
                           <a:latin typeface="Calibri"/>
                         </a:rPr>
-                        <a:t>2,69,773</a:t>
+                        <a:t>269,773</a:t>
                       </a:r>
                     </a:p>
                   </a:txBody>
@@ -10866,7 +10871,7 @@
                           </a:solidFill>
                           <a:latin typeface="Calibri"/>
                         </a:rPr>
-                        <a:t>3,47,583</a:t>
+                        <a:t>347,583</a:t>
                       </a:r>
                     </a:p>
                   </a:txBody>
@@ -14113,7 +14118,7 @@
                 </a:solidFill>
                 <a:latin typeface="Calibri"/>
               </a:rPr>
-              <a:t>- a) Per hour falls; per driver-week falls</a:t>
+              <a:t>a) Per hour falls; per driver-week falls</a:t>
             </a:r>
           </a:p>
           <a:p>
@@ -14129,7 +14134,7 @@
                 </a:solidFill>
                 <a:latin typeface="Calibri"/>
               </a:rPr>
-              <a:t>- b) Per hour falls; per driver-week rises a little</a:t>
+              <a:t>b) Per hour falls; per driver-week rises a little</a:t>
             </a:r>
           </a:p>
           <a:p>
@@ -14145,7 +14150,7 @@
                 </a:solidFill>
                 <a:latin typeface="Calibri"/>
               </a:rPr>
-              <a:t>- c) Per hour holds; per driver-week falls</a:t>
+              <a:t>c) Per hour holds; per driver-week falls</a:t>
             </a:r>
           </a:p>
           <a:p>
@@ -14161,7 +14166,7 @@
                 </a:solidFill>
                 <a:latin typeface="Calibri"/>
               </a:rPr>
-              <a:t>- d) Both hold nearly flat</a:t>
+              <a:t>d) Both hold nearly flat</a:t>
             </a:r>
           </a:p>
           <a:p>
@@ -17353,8 +17358,8 @@
         </p:nvSpPr>
         <p:spPr>
           <a:xfrm>
-            <a:off x="530352" y="1682496"/>
-            <a:ext cx="5291175" cy="1670304"/>
+            <a:off x="530352" y="1822450"/>
+            <a:ext cx="11130991" cy="841248"/>
           </a:xfrm>
           <a:prstGeom prst="rect">
             <a:avLst/>
@@ -17369,11 +17374,11 @@
           <a:p>
             <a:pPr>
               <a:spcAft>
-                <a:spcPts val="700"/>
+                <a:spcPts val="600"/>
               </a:spcAft>
             </a:pPr>
             <a:r>
-              <a:rPr sz="1400" b="1" i="0">
+              <a:rPr sz="1200" b="1" i="0">
                 <a:solidFill>
                   <a:srgbClr val="1A1440"/>
                 </a:solidFill>
@@ -17382,13 +17387,13 @@
               <a:t>Uber, Hyderabad, the driver app's peak-hour earnings guarantee, one day on.</a:t>
             </a:r>
             <a:r>
-              <a:rPr sz="1400" b="0" i="0">
+              <a:rPr sz="1200" b="0" i="0">
                 <a:solidFill>
                   <a:srgbClr val="1A1440"/>
                 </a:solidFill>
                 <a:latin typeface="Calibri"/>
               </a:rPr>
-              <a:t> The city head takes the redesign to Thursday's city review on one slide, in five minutes, with the driver-operations lead, the marketing lead and the finance partner in the room. Each loses something under the redesign and each will say so.</a:t>
+              <a:t> The city head takes the redesign to Thursday's city review on one slide, in five minutes. The driver-operations lead, the marketing lead and the finance partner each lose something under it, and each will say so.</a:t>
             </a:r>
           </a:p>
         </p:txBody>
@@ -17402,8 +17407,8 @@
           <p:nvPr/>
         </p:nvGraphicFramePr>
         <p:xfrm>
-          <a:off x="530352" y="3480816"/>
-          <a:ext cx="5291175" cy="2194560"/>
+          <a:off x="530352" y="2791714"/>
+          <a:ext cx="11130990" cy="1590040"/>
         </p:xfrm>
         <a:graphic>
           <a:graphicData uri="http://schemas.openxmlformats.org/drawingml/2006/table">
@@ -17412,25 +17417,24 @@
                 <a:tableStyleId>{2D5ABB26-0587-4C30-8999-92F81FD0307C}</a:tableStyleId>
               </a:tblPr>
               <a:tblGrid>
-                <a:gridCol w="1789522"/>
-                <a:gridCol w="1243836"/>
-                <a:gridCol w="1343417"/>
-                <a:gridCol w="914400"/>
+                <a:gridCol w="5062503"/>
+                <a:gridCol w="2649835"/>
+                <a:gridCol w="3418652"/>
               </a:tblGrid>
-              <a:tr h="438912">
+              <a:tr h="318008">
                 <a:tc>
                   <a:txBody>
                     <a:bodyPr/>
                     <a:lstStyle/>
                     <a:p>
                       <a:r>
-                        <a:rPr sz="950" b="1" i="0">
+                        <a:rPr sz="1150" b="1" i="0">
                           <a:solidFill>
                             <a:srgbClr val="FFFFFF"/>
                           </a:solidFill>
                           <a:latin typeface="Calibri"/>
                         </a:rPr>
-                        <a:t>The number the slide must explain</a:t>
+                        <a:t>Six weeks each side</a:t>
                       </a:r>
                     </a:p>
                   </a:txBody>
@@ -17446,13 +17450,13 @@
                     <a:lstStyle/>
                     <a:p>
                       <a:r>
-                        <a:rPr sz="950" b="1" i="0">
+                        <a:rPr sz="1150" b="1" i="0">
                           <a:solidFill>
                             <a:srgbClr val="FFFFFF"/>
                           </a:solidFill>
                           <a:latin typeface="Calibri"/>
                         </a:rPr>
-                        <a:t>Six weeks from 20 July</a:t>
+                        <a:t>20 Jul to 30 Aug</a:t>
                       </a:r>
                     </a:p>
                   </a:txBody>
@@ -17468,35 +17472,13 @@
                     <a:lstStyle/>
                     <a:p>
                       <a:r>
-                        <a:rPr sz="950" b="1" i="0">
+                        <a:rPr sz="1150" b="1" i="0">
                           <a:solidFill>
                             <a:srgbClr val="FFFFFF"/>
                           </a:solidFill>
                           <a:latin typeface="Calibri"/>
                         </a:rPr>
-                        <a:t>Six weeks from 31 August</a:t>
-                      </a:r>
-                    </a:p>
-                  </a:txBody>
-                  <a:tcPr marL="101600" marR="101600" marT="38100" marB="38100" anchor="ctr">
-                    <a:solidFill>
-                      <a:srgbClr val="1A0F5C"/>
-                    </a:solidFill>
-                  </a:tcPr>
-                </a:tc>
-                <a:tc>
-                  <a:txBody>
-                    <a:bodyPr/>
-                    <a:lstStyle/>
-                    <a:p>
-                      <a:r>
-                        <a:rPr sz="950" b="1" i="0">
-                          <a:solidFill>
-                            <a:srgbClr val="FFFFFF"/>
-                          </a:solidFill>
-                          <a:latin typeface="Calibri"/>
-                        </a:rPr>
-                        <a:t>Change</a:t>
+                        <a:t>31 Aug to 11 Oct</a:t>
                       </a:r>
                     </a:p>
                   </a:txBody>
@@ -17507,14 +17489,14 @@
                   </a:tcPr>
                 </a:tc>
               </a:tr>
-              <a:tr h="438912">
+              <a:tr h="318008">
                 <a:tc>
                   <a:txBody>
                     <a:bodyPr/>
                     <a:lstStyle/>
                     <a:p>
                       <a:r>
-                        <a:rPr sz="900" b="0" i="0">
+                        <a:rPr sz="1100" b="0" i="0">
                           <a:solidFill>
                             <a:srgbClr val="1A1440"/>
                           </a:solidFill>
@@ -17536,7 +17518,7 @@
                     <a:lstStyle/>
                     <a:p>
                       <a:r>
-                        <a:rPr sz="900" b="0" i="0">
+                        <a:rPr sz="1100" b="0" i="0">
                           <a:solidFill>
                             <a:srgbClr val="1A1440"/>
                           </a:solidFill>
@@ -17558,35 +17540,13 @@
                     <a:lstStyle/>
                     <a:p>
                       <a:r>
-                        <a:rPr sz="900" b="0" i="0">
+                        <a:rPr sz="1100" b="0" i="0">
                           <a:solidFill>
                             <a:srgbClr val="1A1440"/>
                           </a:solidFill>
                           <a:latin typeface="Calibri"/>
                         </a:rPr>
-                        <a:t>Rs 260</a:t>
-                      </a:r>
-                    </a:p>
-                  </a:txBody>
-                  <a:tcPr marL="101600" marR="101600" marT="38100" marB="38100" anchor="ctr">
-                    <a:solidFill>
-                      <a:srgbClr val="FFFFFF"/>
-                    </a:solidFill>
-                  </a:tcPr>
-                </a:tc>
-                <a:tc>
-                  <a:txBody>
-                    <a:bodyPr/>
-                    <a:lstStyle/>
-                    <a:p>
-                      <a:r>
-                        <a:rPr sz="900" b="0" i="0">
-                          <a:solidFill>
-                            <a:srgbClr val="1A1440"/>
-                          </a:solidFill>
-                          <a:latin typeface="Calibri"/>
-                        </a:rPr>
-                        <a:t>down 17 percent</a:t>
+                        <a:t>Rs 260, down 17 percent</a:t>
                       </a:r>
                     </a:p>
                   </a:txBody>
@@ -17597,14 +17557,14 @@
                   </a:tcPr>
                 </a:tc>
               </a:tr>
-              <a:tr h="438912">
+              <a:tr h="318008">
                 <a:tc>
                   <a:txBody>
                     <a:bodyPr/>
                     <a:lstStyle/>
                     <a:p>
                       <a:r>
-                        <a:rPr sz="900" b="0" i="0">
+                        <a:rPr sz="1100" b="0" i="0">
                           <a:solidFill>
                             <a:srgbClr val="1A1440"/>
                           </a:solidFill>
@@ -17626,7 +17586,7 @@
                     <a:lstStyle/>
                     <a:p>
                       <a:r>
-                        <a:rPr sz="900" b="0" i="0">
+                        <a:rPr sz="1100" b="0" i="0">
                           <a:solidFill>
                             <a:srgbClr val="1A1440"/>
                           </a:solidFill>
@@ -17648,35 +17608,13 @@
                     <a:lstStyle/>
                     <a:p>
                       <a:r>
-                        <a:rPr sz="900" b="0" i="0">
+                        <a:rPr sz="1100" b="0" i="0">
                           <a:solidFill>
                             <a:srgbClr val="1A1440"/>
                           </a:solidFill>
                           <a:latin typeface="Calibri"/>
                         </a:rPr>
-                        <a:t>Rs 165</a:t>
-                      </a:r>
-                    </a:p>
-                  </a:txBody>
-                  <a:tcPr marL="101600" marR="101600" marT="38100" marB="38100" anchor="ctr">
-                    <a:solidFill>
-                      <a:srgbClr val="F4F2FA"/>
-                    </a:solidFill>
-                  </a:tcPr>
-                </a:tc>
-                <a:tc>
-                  <a:txBody>
-                    <a:bodyPr/>
-                    <a:lstStyle/>
-                    <a:p>
-                      <a:r>
-                        <a:rPr sz="900" b="0" i="0">
-                          <a:solidFill>
-                            <a:srgbClr val="1A1440"/>
-                          </a:solidFill>
-                          <a:latin typeface="Calibri"/>
-                        </a:rPr>
-                        <a:t>flat</a:t>
+                        <a:t>Rs 165, flat</a:t>
                       </a:r>
                     </a:p>
                   </a:txBody>
@@ -17687,14 +17625,14 @@
                   </a:tcPr>
                 </a:tc>
               </a:tr>
-              <a:tr h="438912">
+              <a:tr h="318008">
                 <a:tc>
                   <a:txBody>
                     <a:bodyPr/>
                     <a:lstStyle/>
                     <a:p>
                       <a:r>
-                        <a:rPr sz="900" b="0" i="0">
+                        <a:rPr sz="1100" b="0" i="0">
                           <a:solidFill>
                             <a:srgbClr val="1A1440"/>
                           </a:solidFill>
@@ -17716,7 +17654,7 @@
                     <a:lstStyle/>
                     <a:p>
                       <a:r>
-                        <a:rPr sz="900" b="0" i="0">
+                        <a:rPr sz="1100" b="0" i="0">
                           <a:solidFill>
                             <a:srgbClr val="1A1440"/>
                           </a:solidFill>
@@ -17738,35 +17676,13 @@
                     <a:lstStyle/>
                     <a:p>
                       <a:r>
-                        <a:rPr sz="900" b="0" i="0">
+                        <a:rPr sz="1100" b="0" i="0">
                           <a:solidFill>
                             <a:srgbClr val="1A1440"/>
                           </a:solidFill>
                           <a:latin typeface="Calibri"/>
                         </a:rPr>
-                        <a:t>Rs 5,861</a:t>
-                      </a:r>
-                    </a:p>
-                  </a:txBody>
-                  <a:tcPr marL="101600" marR="101600" marT="38100" marB="38100" anchor="ctr">
-                    <a:solidFill>
-                      <a:srgbClr val="FFFFFF"/>
-                    </a:solidFill>
-                  </a:tcPr>
-                </a:tc>
-                <a:tc>
-                  <a:txBody>
-                    <a:bodyPr/>
-                    <a:lstStyle/>
-                    <a:p>
-                      <a:r>
-                        <a:rPr sz="900" b="0" i="0">
-                          <a:solidFill>
-                            <a:srgbClr val="1A1440"/>
-                          </a:solidFill>
-                          <a:latin typeface="Calibri"/>
-                        </a:rPr>
-                        <a:t>up 0.8 percent</a:t>
+                        <a:t>Rs 5,861, up 0.8 percent</a:t>
                       </a:r>
                     </a:p>
                   </a:txBody>
@@ -17777,14 +17693,14 @@
                   </a:tcPr>
                 </a:tc>
               </a:tr>
-              <a:tr h="438912">
+              <a:tr h="318008">
                 <a:tc>
                   <a:txBody>
                     <a:bodyPr/>
                     <a:lstStyle/>
                     <a:p>
                       <a:r>
-                        <a:rPr sz="900" b="0" i="0">
+                        <a:rPr sz="1100" b="0" i="0">
                           <a:solidFill>
                             <a:srgbClr val="1A1440"/>
                           </a:solidFill>
@@ -17806,13 +17722,13 @@
                     <a:lstStyle/>
                     <a:p>
                       <a:r>
-                        <a:rPr sz="900" b="0" i="0">
+                        <a:rPr sz="1100" b="0" i="0">
                           <a:solidFill>
                             <a:srgbClr val="1A1440"/>
                           </a:solidFill>
                           <a:latin typeface="Calibri"/>
                         </a:rPr>
-                        <a:t>1,18,000</a:t>
+                        <a:t>118,000</a:t>
                       </a:r>
                     </a:p>
                   </a:txBody>
@@ -17828,35 +17744,13 @@
                     <a:lstStyle/>
                     <a:p>
                       <a:r>
-                        <a:rPr sz="900" b="0" i="0">
+                        <a:rPr sz="1100" b="0" i="0">
                           <a:solidFill>
                             <a:srgbClr val="1A1440"/>
                           </a:solidFill>
                           <a:latin typeface="Calibri"/>
                         </a:rPr>
-                        <a:t>1,46,300</a:t>
-                      </a:r>
-                    </a:p>
-                  </a:txBody>
-                  <a:tcPr marL="101600" marR="101600" marT="38100" marB="38100" anchor="ctr">
-                    <a:solidFill>
-                      <a:srgbClr val="F4F2FA"/>
-                    </a:solidFill>
-                  </a:tcPr>
-                </a:tc>
-                <a:tc>
-                  <a:txBody>
-                    <a:bodyPr/>
-                    <a:lstStyle/>
-                    <a:p>
-                      <a:r>
-                        <a:rPr sz="900" b="0" i="0">
-                          <a:solidFill>
-                            <a:srgbClr val="1A1440"/>
-                          </a:solidFill>
-                          <a:latin typeface="Calibri"/>
-                        </a:rPr>
-                        <a:t>up 24 percent</a:t>
+                        <a:t>146,300, up 24 percent</a:t>
                       </a:r>
                     </a:p>
                   </a:txBody>
@@ -17879,8 +17773,8 @@
         </p:nvSpPr>
         <p:spPr>
           <a:xfrm>
-            <a:off x="6370167" y="1682496"/>
-            <a:ext cx="5291175" cy="2585719"/>
+            <a:off x="530352" y="4637786"/>
+            <a:ext cx="11130991" cy="861060"/>
           </a:xfrm>
           <a:prstGeom prst="roundRect">
             <a:avLst>
@@ -17927,8 +17821,8 @@
         </p:nvSpPr>
         <p:spPr>
           <a:xfrm>
-            <a:off x="6516471" y="1810512"/>
-            <a:ext cx="45720" cy="2329687"/>
+            <a:off x="676656" y="4765802"/>
+            <a:ext cx="45720" cy="605028"/>
           </a:xfrm>
           <a:prstGeom prst="roundRect">
             <a:avLst>
@@ -17973,8 +17867,8 @@
         </p:nvSpPr>
         <p:spPr>
           <a:xfrm>
-            <a:off x="6717639" y="1801368"/>
-            <a:ext cx="4724247" cy="2402839"/>
+            <a:off x="877824" y="4756658"/>
+            <a:ext cx="10564063" cy="678180"/>
           </a:xfrm>
           <a:prstGeom prst="rect">
             <a:avLst/>
@@ -17988,7 +17882,7 @@
           <a:lstStyle/>
           <a:p>
             <a:r>
-              <a:rPr sz="1300" b="1">
+              <a:rPr sz="1100" b="1">
                 <a:solidFill>
                   <a:srgbClr val="5B3FD6"/>
                 </a:solidFill>
@@ -17997,16 +17891,16 @@
               <a:t>Data. </a:t>
             </a:r>
             <a:r>
-              <a:rPr sz="1300" b="0" i="0">
+              <a:rPr sz="1100" b="0" i="0">
                 <a:solidFill>
                   <a:srgbClr val="1A1440"/>
                 </a:solidFill>
                 <a:latin typeface="Calibri"/>
               </a:rPr>
-              <a:t>Monday's tables: driver_weeks (one row per driver per week, with peak_online_hours, peak_trips, peak_bookings_rs, topup_rs) and zone_weeks (rider requests and median wait by zone and week). </a:t>
-            </a:r>
-            <a:r>
-              <a:rPr sz="1300" b="1" i="0">
+              <a:t>Monday's driver_weeks and zone_weeks. </a:t>
+            </a:r>
+            <a:r>
+              <a:rPr sz="1100" b="1" i="0">
                 <a:solidFill>
                   <a:srgbClr val="1A1440"/>
                 </a:solidFill>
@@ -18015,16 +17909,16 @@
               <a:t>The afternoon ask.</a:t>
             </a:r>
             <a:r>
-              <a:rPr sz="1300" b="0" i="0">
+              <a:rPr sz="1100" b="0" i="0">
                 <a:solidFill>
                   <a:srgbClr val="1A1440"/>
                 </a:solidFill>
                 <a:latin typeface="Calibri"/>
               </a:rPr>
-              <a:t> Roughly how many drivers must be online at the weekday evening peak to keep the median rider wait under five minutes, in fifteen minutes, without a dataset. </a:t>
-            </a:r>
-            <a:r>
-              <a:rPr sz="1300" b="1" i="0">
+              <a:t> How many drivers must be online at the weekday evening peak to keep the median rider wait under five minutes, sized in fifteen minutes without a dataset. </a:t>
+            </a:r>
+            <a:r>
+              <a:rPr sz="1100" b="1" i="0">
                 <a:solidFill>
                   <a:srgbClr val="1A1440"/>
                 </a:solidFill>
@@ -18033,13 +17927,13 @@
               <a:t>Caveats.</a:t>
             </a:r>
             <a:r>
-              <a:rPr sz="1300" b="0" i="0">
+              <a:rPr sz="1100" b="0" i="0">
                 <a:solidFill>
                   <a:srgbClr val="1A1440"/>
                 </a:solidFill>
                 <a:latin typeface="Calibri"/>
               </a:rPr>
-              <a:t> Each objection is partly right; the peak window is three hours long; no published figure exists for the number a sanity check on the afternoon ask would want.</a:t>
+              <a:t> Each objection is partly right; the peak window is three hours long; no published figure exists to check the afternoon's answer against.</a:t>
             </a:r>
           </a:p>
         </p:txBody>
@@ -18052,8 +17946,8 @@
         </p:nvSpPr>
         <p:spPr>
           <a:xfrm>
-            <a:off x="6370167" y="4432807"/>
-            <a:ext cx="45720" cy="929640"/>
+            <a:off x="530352" y="5663438"/>
+            <a:ext cx="45720" cy="396240"/>
           </a:xfrm>
           <a:prstGeom prst="roundRect">
             <a:avLst>
@@ -18098,8 +17992,8 @@
         </p:nvSpPr>
         <p:spPr>
           <a:xfrm>
-            <a:off x="6626199" y="4432807"/>
-            <a:ext cx="4980279" cy="929640"/>
+            <a:off x="786384" y="5663438"/>
+            <a:ext cx="10820095" cy="396240"/>
           </a:xfrm>
           <a:prstGeom prst="rect">
             <a:avLst/>
@@ -18113,7 +18007,7 @@
           <a:lstStyle/>
           <a:p>
             <a:r>
-              <a:rPr sz="1400" b="0" i="1">
+              <a:rPr sz="1200" b="0" i="1">
                 <a:solidFill>
                   <a:srgbClr val="1A0F5C"/>
                 </a:solidFill>
@@ -18639,7 +18533,7 @@
       </p:sp>
       <p:pic>
         <p:nvPicPr>
-          <p:cNvPr id="9" name="mermaid diagram" descr="2a1d5801311aac30.png"/>
+          <p:cNvPr id="9" name="mermaid diagram" descr="4d8a47354834f8c3.png"/>
           <p:cNvPicPr>
             <a:picLocks noChangeAspect="1"/>
           </p:cNvPicPr>
@@ -18653,8 +18547,8 @@
         </p:blipFill>
         <p:spPr>
           <a:xfrm>
-            <a:off x="2152497" y="1901952"/>
-            <a:ext cx="7886700" cy="2857500"/>
+            <a:off x="2152497" y="1956816"/>
+            <a:ext cx="7886700" cy="2100262"/>
           </a:xfrm>
           <a:prstGeom prst="rect">
             <a:avLst/>
@@ -18663,67 +18557,101 @@
       </p:pic>
       <p:sp>
         <p:nvSpPr>
-          <p:cNvPr id="10" name="Rounded Rectangle 9"/>
+          <p:cNvPr id="10" name="TextBox 9"/>
+          <p:cNvSpPr txBox="1"/>
+          <p:nvPr/>
+        </p:nvSpPr>
+        <p:spPr>
+          <a:xfrm>
+            <a:off x="530352" y="4203382"/>
+            <a:ext cx="11130991" cy="1324864"/>
+          </a:xfrm>
+          <a:prstGeom prst="rect">
+            <a:avLst/>
+          </a:prstGeom>
+          <a:noFill/>
+        </p:spPr>
+        <p:txBody>
+          <a:bodyPr wrap="square" anchor="t" lIns="0" rIns="0" tIns="0" bIns="0">
+            <a:spAutoFit/>
+          </a:bodyPr>
+          <a:lstStyle/>
+          <a:p>
+            <a:pPr>
+              <a:spcAft>
+                <a:spcPts val="800"/>
+              </a:spcAft>
+            </a:pPr>
+            <a:r>
+              <a:rPr sz="1600" b="1" i="0">
+                <a:solidFill>
+                  <a:srgbClr val="1A1440"/>
+                </a:solidFill>
+                <a:latin typeface="Calibri"/>
+              </a:rPr>
+              <a:t>Chapter 1 adds</a:t>
+            </a:r>
+            <a:r>
+              <a:rPr sz="1600" b="0" i="0">
+                <a:solidFill>
+                  <a:srgbClr val="1A1440"/>
+                </a:solidFill>
+                <a:latin typeface="Calibri"/>
+              </a:rPr>
+              <a:t> the claim (the scheme pays for idle hours) and its denominator (Rs 314 to Rs 260 per peak online hour). </a:t>
+            </a:r>
+            <a:r>
+              <a:rPr sz="1600" b="1" i="0">
+                <a:solidFill>
+                  <a:srgbClr val="1A1440"/>
+                </a:solidFill>
+                <a:latin typeface="Calibri"/>
+              </a:rPr>
+              <a:t>Said plainly:</a:t>
+            </a:r>
+            <a:r>
+              <a:rPr sz="1600" b="0" i="0">
+                <a:solidFill>
+                  <a:srgbClr val="1A1440"/>
+                </a:solidFill>
+                <a:latin typeface="Calibri"/>
+              </a:rPr>
+              <a:t> "An hour online used to bring in Rs 314 of fares and now brings in Rs 260, because more of those hours have no rider." </a:t>
+            </a:r>
+            <a:r>
+              <a:rPr sz="1600" b="1" i="0">
+                <a:solidFill>
+                  <a:srgbClr val="1A1440"/>
+                </a:solidFill>
+                <a:latin typeface="Calibri"/>
+              </a:rPr>
+              <a:t>In the interview</a:t>
+            </a:r>
+            <a:r>
+              <a:rPr sz="1600" b="0" i="0">
+                <a:solidFill>
+                  <a:srgbClr val="1A1440"/>
+                </a:solidFill>
+                <a:latin typeface="Calibri"/>
+              </a:rPr>
+              <a:t> [S]: present a recommendation to a non-technical stakeholder in two minutes, opening on that sentence.</a:t>
+            </a:r>
+          </a:p>
+        </p:txBody>
+      </p:sp>
+      <p:sp>
+        <p:nvSpPr>
+          <p:cNvPr id="11" name="Oval 10"/>
           <p:cNvSpPr/>
           <p:nvPr/>
         </p:nvSpPr>
         <p:spPr>
           <a:xfrm>
-            <a:off x="530352" y="4905756"/>
-            <a:ext cx="11130991" cy="1074420"/>
-          </a:xfrm>
-          <a:prstGeom prst="roundRect">
-            <a:avLst>
-              <a:gd name="adj" fmla="val 8000"/>
-            </a:avLst>
-          </a:prstGeom>
-          <a:solidFill>
-            <a:srgbClr val="F7F5FD"/>
-          </a:solidFill>
-          <a:ln w="9525">
-            <a:solidFill>
-              <a:srgbClr val="E4E1F1"/>
-            </a:solidFill>
-          </a:ln>
-          <a:effectLst/>
-        </p:spPr>
-        <p:style>
-          <a:lnRef idx="1">
-            <a:schemeClr val="accent1"/>
-          </a:lnRef>
-          <a:fillRef idx="3">
-            <a:schemeClr val="accent1"/>
-          </a:fillRef>
-          <a:effectRef idx="2">
-            <a:schemeClr val="accent1"/>
-          </a:effectRef>
-          <a:fontRef idx="minor">
-            <a:schemeClr val="lt1"/>
-          </a:fontRef>
-        </p:style>
-        <p:txBody>
-          <a:bodyPr rtlCol="0" anchor="ctr" wrap="square"/>
-          <a:lstStyle/>
-          <a:p>
-            <a:pPr algn="ctr"/>
-          </a:p>
-        </p:txBody>
-      </p:sp>
-      <p:sp>
-        <p:nvSpPr>
-          <p:cNvPr id="11" name="Rounded Rectangle 10"/>
-          <p:cNvSpPr/>
-          <p:nvPr/>
-        </p:nvSpPr>
-        <p:spPr>
-          <a:xfrm>
-            <a:off x="676656" y="5033772"/>
-            <a:ext cx="45720" cy="818388"/>
-          </a:xfrm>
-          <a:prstGeom prst="roundRect">
-            <a:avLst>
-              <a:gd name="adj" fmla="val 50000"/>
-            </a:avLst>
+            <a:off x="530352" y="6492240"/>
+            <a:ext cx="64008" cy="64008"/>
+          </a:xfrm>
+          <a:prstGeom prst="ellipse">
+            <a:avLst/>
           </a:prstGeom>
           <a:solidFill>
             <a:srgbClr val="5B3FD6"/>
@@ -18763,111 +18691,6 @@
         </p:nvSpPr>
         <p:spPr>
           <a:xfrm>
-            <a:off x="877824" y="5024628"/>
-            <a:ext cx="10564063" cy="891540"/>
-          </a:xfrm>
-          <a:prstGeom prst="rect">
-            <a:avLst/>
-          </a:prstGeom>
-          <a:noFill/>
-        </p:spPr>
-        <p:txBody>
-          <a:bodyPr wrap="square" anchor="ctr" lIns="0" rIns="0" tIns="0" bIns="0">
-            <a:spAutoFit/>
-          </a:bodyPr>
-          <a:lstStyle/>
-          <a:p>
-            <a:r>
-              <a:rPr sz="1500" b="1">
-                <a:solidFill>
-                  <a:srgbClr val="5B3FD6"/>
-                </a:solidFill>
-                <a:latin typeface="Calibri"/>
-              </a:rPr>
-              <a:t>Said plainly: </a:t>
-            </a:r>
-            <a:r>
-              <a:rPr sz="1500" b="0" i="0">
-                <a:solidFill>
-                  <a:srgbClr val="1A1440"/>
-                </a:solidFill>
-                <a:latin typeface="Calibri"/>
-              </a:rPr>
-              <a:t>"An hour online used to bring in Rs 314 of fares and now brings in Rs 260, because more of those hours have no rider." </a:t>
-            </a:r>
-            <a:r>
-              <a:rPr sz="1500" b="1" i="0">
-                <a:solidFill>
-                  <a:srgbClr val="1A1440"/>
-                </a:solidFill>
-                <a:latin typeface="Calibri"/>
-              </a:rPr>
-              <a:t>In the interview</a:t>
-            </a:r>
-            <a:r>
-              <a:rPr sz="1500" b="0" i="0">
-                <a:solidFill>
-                  <a:srgbClr val="1A1440"/>
-                </a:solidFill>
-                <a:latin typeface="Calibri"/>
-              </a:rPr>
-              <a:t> [S]: present a recommendation to a non-technical stakeholder in two minutes, opening on that sentence.</a:t>
-            </a:r>
-          </a:p>
-        </p:txBody>
-      </p:sp>
-      <p:sp>
-        <p:nvSpPr>
-          <p:cNvPr id="13" name="Oval 12"/>
-          <p:cNvSpPr/>
-          <p:nvPr/>
-        </p:nvSpPr>
-        <p:spPr>
-          <a:xfrm>
-            <a:off x="530352" y="6492240"/>
-            <a:ext cx="64008" cy="64008"/>
-          </a:xfrm>
-          <a:prstGeom prst="ellipse">
-            <a:avLst/>
-          </a:prstGeom>
-          <a:solidFill>
-            <a:srgbClr val="5B3FD6"/>
-          </a:solidFill>
-          <a:ln>
-            <a:noFill/>
-          </a:ln>
-          <a:effectLst/>
-        </p:spPr>
-        <p:style>
-          <a:lnRef idx="1">
-            <a:schemeClr val="accent1"/>
-          </a:lnRef>
-          <a:fillRef idx="3">
-            <a:schemeClr val="accent1"/>
-          </a:fillRef>
-          <a:effectRef idx="2">
-            <a:schemeClr val="accent1"/>
-          </a:effectRef>
-          <a:fontRef idx="minor">
-            <a:schemeClr val="lt1"/>
-          </a:fontRef>
-        </p:style>
-        <p:txBody>
-          <a:bodyPr rtlCol="0" anchor="ctr" wrap="square"/>
-          <a:lstStyle/>
-          <a:p>
-            <a:pPr algn="ctr"/>
-          </a:p>
-        </p:txBody>
-      </p:sp>
-      <p:sp>
-        <p:nvSpPr>
-          <p:cNvPr id="14" name="TextBox 13"/>
-          <p:cNvSpPr txBox="1"/>
-          <p:nvPr/>
-        </p:nvSpPr>
-        <p:spPr>
-          <a:xfrm>
             <a:off x="640080" y="6437376"/>
             <a:ext cx="1286446" cy="152146"/>
           </a:xfrm>
@@ -18897,7 +18720,7 @@
       </p:sp>
       <p:sp>
         <p:nvSpPr>
-          <p:cNvPr id="15" name="Oval 14"/>
+          <p:cNvPr id="13" name="Oval 12"/>
           <p:cNvSpPr/>
           <p:nvPr/>
         </p:nvSpPr>
@@ -18941,7 +18764,7 @@
       </p:sp>
       <p:sp>
         <p:nvSpPr>
-          <p:cNvPr id="16" name="TextBox 15"/>
+          <p:cNvPr id="14" name="TextBox 13"/>
           <p:cNvSpPr txBox="1"/>
           <p:nvPr/>
         </p:nvSpPr>
@@ -18976,7 +18799,7 @@
       </p:sp>
       <p:sp>
         <p:nvSpPr>
-          <p:cNvPr id="17" name="Oval 16"/>
+          <p:cNvPr id="15" name="Oval 14"/>
           <p:cNvSpPr/>
           <p:nvPr/>
         </p:nvSpPr>
@@ -19020,7 +18843,7 @@
       </p:sp>
       <p:sp>
         <p:nvSpPr>
-          <p:cNvPr id="18" name="TextBox 17"/>
+          <p:cNvPr id="16" name="TextBox 15"/>
           <p:cNvSpPr txBox="1"/>
           <p:nvPr/>
         </p:nvSpPr>
@@ -19055,7 +18878,7 @@
       </p:sp>
       <p:sp>
         <p:nvSpPr>
-          <p:cNvPr id="19" name="TextBox 18"/>
+          <p:cNvPr id="17" name="TextBox 16"/>
           <p:cNvSpPr txBox="1"/>
           <p:nvPr/>
         </p:nvSpPr>
@@ -19874,7 +19697,7 @@
                 </a:solidFill>
                 <a:latin typeface="Calibri"/>
               </a:rPr>
-              <a:t>- a) The driver-operations lead: "Drivers will log off and supply at peak will fall"</a:t>
+              <a:t>a) The driver-operations lead: "Drivers will log off and supply at peak will fall"</a:t>
             </a:r>
           </a:p>
           <a:p>
@@ -19890,7 +19713,7 @@
                 </a:solidFill>
                 <a:latin typeface="Calibri"/>
               </a:rPr>
-              <a:t>- b) The marketing lead: "The guarantee is on every hoarding; changing it six weeks in looks like bait"</a:t>
+              <a:t>b) The marketing lead: "The guarantee is on every hoarding; changing it six weeks in looks like bait"</a:t>
             </a:r>
           </a:p>
           <a:p>
@@ -19906,7 +19729,7 @@
                 </a:solidFill>
                 <a:latin typeface="Calibri"/>
               </a:rPr>
-              <a:t>- c) The finance partner: "The fall in bookings per hour is the monsoon ending, not the scheme"</a:t>
+              <a:t>c) The finance partner: "The fall in bookings per hour is the monsoon ending"</a:t>
             </a:r>
           </a:p>
           <a:p>
@@ -19922,7 +19745,7 @@
                 </a:solidFill>
                 <a:latin typeface="Calibri"/>
               </a:rPr>
-              <a:t>- d) None of them outright, because each objection is partly right</a:t>
+              <a:t>d) None of them outright, because each objection is partly right</a:t>
             </a:r>
           </a:p>
         </p:txBody>
@@ -20588,7 +20411,7 @@
                           </a:solidFill>
                           <a:latin typeface="Calibri"/>
                         </a:rPr>
-                        <a:t>The other 1,020 drivers held at 1.90 to 1.89 trips per online hour and keep the floor if they accept</a:t>
+                        <a:t>The other 880 drivers, there before the launch, held at 1.90 trips per online hour and keep the floor if they accept</a:t>
                       </a:r>
                     </a:p>
                   </a:txBody>
@@ -27727,7 +27550,7 @@
                 </a:solidFill>
                 <a:latin typeface="Calibri"/>
               </a:rPr>
-              <a:t>- a) The caveat that the monsoon ended inside the window</a:t>
+              <a:t>a) The caveat that the monsoon ended inside the window</a:t>
             </a:r>
           </a:p>
           <a:p>
@@ -27743,7 +27566,7 @@
                 </a:solidFill>
                 <a:latin typeface="Calibri"/>
               </a:rPr>
-              <a:t>- b) The per-driver-week and per-trip reads, with one line each on what moved them</a:t>
+              <a:t>b) The per-driver-week and per-trip reads, with one line each on what moved them</a:t>
             </a:r>
           </a:p>
           <a:p>
@@ -27759,7 +27582,7 @@
                 </a:solidFill>
                 <a:latin typeface="Calibri"/>
               </a:rPr>
-              <a:t>- c) The action and its saving range</a:t>
+              <a:t>c) The action and its saving range</a:t>
             </a:r>
           </a:p>
           <a:p>
@@ -27775,7 +27598,7 @@
                 </a:solidFill>
                 <a:latin typeface="Calibri"/>
               </a:rPr>
-              <a:t>- d) The chart of bookings per peak online hour</a:t>
+              <a:t>d) The chart of bookings per peak online hour</a:t>
             </a:r>
           </a:p>
         </p:txBody>
@@ -33135,7 +32958,7 @@
                 </a:solidFill>
                 <a:latin typeface="Georgia"/>
               </a:rPr>
-              <a:t>"The scheme is paying for online hours that carry no trips: gross bookings per peak online hour fell from Rs 314 to Rs 260 while the fare held at Rs 165. The monsoon ended inside the window, so part of the fall may be the season. Pay per completed peak trip with an acceptance floor; that returns Rs 58 lakh to Rs 93 lakh over six weeks if a fifth to a half of the idle drivers start accepting."</a:t>
+              <a:t>"The scheme is paying for online hours that carry no trips: gross bookings per peak online hour fell from Rs 314 to Rs 260 while the fare held at Rs 165. The monsoon ended inside the window, so part of the fall may be the season. Pay per completed peak trip with an acceptance floor; that returns Rs 58 lakh to Rs 92.7 lakh over six weeks depending on whether half or a fifth of the idle drivers start accepting."</a:t>
             </a:r>
           </a:p>
         </p:txBody>
@@ -35577,7 +35400,7 @@
                 </a:solidFill>
                 <a:latin typeface="Calibri"/>
               </a:rPr>
-              <a:t>- a) Peak guarantee: six-week review</a:t>
+              <a:t>a) Peak guarantee: six-week review</a:t>
             </a:r>
           </a:p>
           <a:p>
@@ -35593,7 +35416,7 @@
                 </a:solidFill>
                 <a:latin typeface="Calibri"/>
               </a:rPr>
-              <a:t>- b) Online hours up 24 percent, trips up 3 percent</a:t>
+              <a:t>b) Online hours up 24 percent, trips up 3 percent</a:t>
             </a:r>
           </a:p>
           <a:p>
@@ -35609,7 +35432,7 @@
                 </a:solidFill>
                 <a:latin typeface="Calibri"/>
               </a:rPr>
-              <a:t>- c) The scheme pays for idle hours: pay per completed trip</a:t>
+              <a:t>c) The scheme pays for idle hours: pay per completed trip</a:t>
             </a:r>
           </a:p>
           <a:p>
@@ -35625,7 +35448,7 @@
                 </a:solidFill>
                 <a:latin typeface="Calibri"/>
               </a:rPr>
-              <a:t>- d) Hyderabad operations update, October</a:t>
+              <a:t>d) Hyderabad operations update, October</a:t>
             </a:r>
           </a:p>
           <a:p>

</xml_diff>

<commit_message>
W04 D2 chapter 2 keeps the spine's prediction: whose side the city head is on
Co-Authored-By: Claude Opus 5.5 <noreply@anthropic.com>
Claude-Session: https://claude.ai/code/session_01USyZ9LfgL4fjeuMBVArE8h
</commit_message>
<xml_diff>
--- a/content/W04/D2/slides/C2_W04_D02_half1_STUDENT.pptx
+++ b/content/W04/D2/slides/C2_W04_D02_half1_STUDENT.pptx
@@ -1671,7 +1671,7 @@
           </a:p>
           <a:p>
             <a:r>
-              <a:t>votes on a, since it is the number everyone quotes.</a:t>
+              <a:t>votes on c, since the monsoon sounds like the safest explanation.</a:t>
             </a:r>
           </a:p>
           <a:p>
@@ -18941,7 +18941,7 @@
                 </a:solidFill>
                 <a:latin typeface="Georgia"/>
               </a:rPr>
-              <a:t>Predict: which line best answers the monsoon?</a:t>
+              <a:t>Predict: which role will the city head side with?</a:t>
             </a:r>
           </a:p>
         </p:txBody>
@@ -18976,7 +18976,7 @@
                 </a:solidFill>
                 <a:latin typeface="Calibri"/>
               </a:rPr>
-              <a:t>The finance partner says the fall is the monsoon ending. Which line of evidence answers it best?</a:t>
+              <a:t>When the three objections land, whose side is the city head on?</a:t>
             </a:r>
           </a:p>
         </p:txBody>
@@ -19015,7 +19015,7 @@
                 </a:solidFill>
                 <a:latin typeface="Calibri"/>
               </a:rPr>
-              <a:t>a) Rider requests rose 1.8 percent across the six weeks after the launch, so demand never fell</a:t>
+              <a:t>a) The driver-operations lead: "Drivers will log off and supply at peak will fall"</a:t>
             </a:r>
           </a:p>
           <a:p>
@@ -19031,7 +19031,7 @@
                 </a:solidFill>
                 <a:latin typeface="Calibri"/>
               </a:rPr>
-              <a:t>b) With requests back at the before level, the last three weeks still ran at 1.56 trips an hour</a:t>
+              <a:t>b) The marketing lead: "The guarantee is on every hoarding; changing it six weeks in looks like bait"</a:t>
             </a:r>
           </a:p>
           <a:p>
@@ -19047,7 +19047,7 @@
                 </a:solidFill>
                 <a:latin typeface="Calibri"/>
               </a:rPr>
-              <a:t>c) Bookings per active driver-week rose 0.8 percent, so drivers still earned</a:t>
+              <a:t>c) The finance partner: "The fall in bookings per hour is the monsoon ending"</a:t>
             </a:r>
           </a:p>
           <a:p>
@@ -19063,7 +19063,7 @@
                 </a:solidFill>
                 <a:latin typeface="Calibri"/>
               </a:rPr>
-              <a:t>d) The 140 drivers who joined after the launch drove only some weeks</a:t>
+              <a:t>d) None of them outright, because each objection is partly right</a:t>
             </a:r>
           </a:p>
         </p:txBody>
@@ -19541,7 +19541,7 @@
                 </a:solidFill>
                 <a:latin typeface="Georgia"/>
               </a:rPr>
-              <a:t>Answer: the last three weeks answer the monsoon</a:t>
+              <a:t>Answer: each objection is partly right</a:t>
             </a:r>
           </a:p>
         </p:txBody>
@@ -20003,7 +20003,7 @@
                 </a:solidFill>
                 <a:latin typeface="Calibri"/>
               </a:rPr>
-              <a:t>The answer is b. </a:t>
+              <a:t>The answer is d. </a:t>
             </a:r>
             <a:r>
               <a:rPr sz="1500" b="0" i="0">
@@ -20012,7 +20012,7 @@
                 </a:solidFill>
                 <a:latin typeface="Calibri"/>
               </a:rPr>
-              <a:t>Weekly requests fell four weeks running from 7 September, so a's six-week average hides a slide; in the last three weeks they sat inside the before window's weekly range, and trips per hour stayed at 1.56. c is the per-driver-week trap, and d explains the denominator, never the fall.</a:t>
+              <a:t>A defence that sides with no one concedes each true part out loud and answers the rest from a line of evidence. Finance's row is the hardest: weekly requests fell four weeks running from 7 September, so the six-week rise of 1.8 percent hides a slide; the last three weeks answer it.</a:t>
             </a:r>
           </a:p>
         </p:txBody>

</xml_diff>

<commit_message>
W04 D2 decks: the humanizer read, explorer scenes named, the handoff line on S56
The cover's afternoon ask is a sentence, the morning's garden paths and fragments read once, S9, S10, S14 and S40 name the explorer scene each uses, and S56's notes carry the day sheet's handoff line. Both decks rebuilt: 35 and 27 slides.

Co-Authored-By: Claude Opus 5.5 <noreply@anthropic.com>
Claude-Session: https://claude.ai/code/session_01USyZ9LfgL4fjeuMBVArE8h
</commit_message>
<xml_diff>
--- a/content/W04/D2/slides/C2_W04_D02_half1_STUDENT.pptx
+++ b/content/W04/D2/slides/C2_W04_D02_half1_STUDENT.pptx
@@ -656,6 +656,11 @@
           </a:p>
           <a:p>
             <a:r>
+              <a:t>Explorer scene T1 stays on slide A's nine numbers until every letter is in; nothing is unticked yet.</a:t>
+            </a:r>
+          </a:p>
+          <a:p>
+            <a:r>
               <a:t>Transition: the rebuild.</a:t>
             </a:r>
           </a:p>
@@ -746,7 +751,12 @@
           </a:p>
           <a:p>
             <a:r>
-              <a:t>the bar pair, is the evidence.</a:t>
+              <a:t>the bar pair, is the evidence. In explorer scene T1, untick the seven numbers that leave, one at a time,</a:t>
+            </a:r>
+          </a:p>
+          <a:p>
+            <a:r>
+              <a:t>as each part is pointed at.</a:t>
             </a:r>
           </a:p>
           <a:p>
@@ -1097,6 +1107,11 @@
           <a:p>
             <a:r>
               <a:t>Each learner writes a letter. Expect votes on a, since new drivers are the obvious change.</a:t>
+            </a:r>
+          </a:p>
+          <a:p>
+            <a:r>
+              <a:t>Explorer scene T2, the denominator picker, stays closed until every letter is written; it opens on S15.</a:t>
             </a:r>
           </a:p>
           <a:p>
@@ -6723,7 +6738,7 @@
                 </a:solidFill>
                 <a:latin typeface="Calibri"/>
               </a:rPr>
-              <a:t> Thursday's city review gets one slide, five minutes, and three people who each lose under it. Gross bookings are what riders paid; an active driver-week is one driver with a row that week.</a:t>
+              <a:t> Thursday's city review gets one slide, five minutes, and three people who each lose under the redesign. Gross bookings are what riders paid; an active driver-week is one driver with a row that week.</a:t>
             </a:r>
           </a:p>
         </p:txBody>
@@ -7245,7 +7260,7 @@
                 </a:solidFill>
                 <a:latin typeface="Calibri"/>
               </a:rPr>
-              <a:t> Drivers online at the three-hour weekday evening peak for a median wait under five minutes, in fifteen minutes. </a:t>
+              <a:t> Estimate, in fifteen minutes, how many drivers must be online at the three-hour weekday evening peak for a median wait under five minutes. </a:t>
             </a:r>
             <a:r>
               <a:rPr sz="1300" b="1" i="0">
@@ -8704,7 +8719,7 @@
                 </a:solidFill>
                 <a:latin typeface="Calibri"/>
               </a:rPr>
-              <a:t>Trips per online hour falling at a flat fare is bookings per online hour falling, Rs 314 to Rs 260: that is the chart. The 61 percent, the one number beside it, says where the top-up went. Option a is Monday's trap resold: online hours rose 24 percent while riders barely gained.</a:t>
+              <a:t>At a flat fare, fewer trips per online hour means lower bookings per online hour, Rs 314 to Rs 260, and that fall is the chart. The 61 percent, the one number beside it, says where the top-up went. Option a is Monday's trap resold: online hours rose 24 percent while riders barely gained.</a:t>
             </a:r>
           </a:p>
         </p:txBody>
@@ -14041,7 +14056,7 @@
                 </a:solidFill>
                 <a:latin typeface="Calibri"/>
               </a:rPr>
-              <a:t>On the six drivers per driver-week fell 23 percent; on the city it rose 0.8 percent. Why?</a:t>
+              <a:t>On the six drivers, rupees per driver-week fell 23 percent; city-wide, it rose 0.8 percent. Why?</a:t>
             </a:r>
           </a:p>
         </p:txBody>
@@ -14089,7 +14104,7 @@
                 </a:solidFill>
                 <a:latin typeface="Calibri"/>
               </a:rPr>
-              <a:t> Rs 1,800 on Monday from 20 rides in 9 hours, and Rs 1,800 on Tuesday from 18 rides in 12 hours: per day flat, per ride up from Rs 90 to Rs 100, per hour down from Rs 200 to Rs 150. The denominator picks the direction.</a:t>
+              <a:t> The driver earns Rs 1,800 on Monday from 20 rides in 9 hours and Rs 1,800 on Tuesday from 18 rides in 12 hours, so the denominator picks the direction: per day is flat, per ride rises from Rs 90 to Rs 100 and per hour falls from Rs 200 to Rs 150.</a:t>
             </a:r>
           </a:p>
           <a:p>
@@ -14666,7 +14681,7 @@
                 </a:solidFill>
                 <a:latin typeface="Calibri"/>
               </a:rPr>
-              <a:t>How can per driver-week rise while per hour falls?</a:t>
+              <a:t>How can rupees per driver-week rise while rupees per hour fall?</a:t>
             </a:r>
           </a:p>
         </p:txBody>
@@ -15649,7 +15664,7 @@
                 </a:solidFill>
                 <a:latin typeface="Calibri"/>
               </a:rPr>
-              <a:t>Bookings rose 3.0 percent and active driver-weeks 2.2 percent (6,360 to 6,500), so the ratio rose 0.8 percent (1.030 / 1.022 = 1.008). The rise was bought with hours: 21 percent more online hours a driver-week for 17 percent less per hour. The 140 drivers who joined after the launch drove about one week each, at Rs 4,314 a driver-week, so they pulled the read down; the drivers there before the launch rose 1.4 percent.</a:t>
+              <a:t>Bookings rose 3.0 percent and active driver-weeks 2.2 percent (6,360 to 6,500), so the ratio rose 0.8 percent (1.030 / 1.022 = 1.008). The rise was bought with hours: 21 percent more online hours a driver-week for 17 percent less per hour. The 140 drivers who joined after the launch drove about one week each, at Rs 4,314 a driver-week, so they pulled the read down; for the drivers there before the launch, it rose 1.4 percent.</a:t>
             </a:r>
           </a:p>
         </p:txBody>
@@ -15663,7 +15678,7 @@
         <p:spPr>
           <a:xfrm>
             <a:off x="530352" y="4968240"/>
-            <a:ext cx="11130991" cy="541020"/>
+            <a:ext cx="11130991" cy="807720"/>
           </a:xfrm>
           <a:prstGeom prst="roundRect">
             <a:avLst>
@@ -15711,7 +15726,7 @@
         <p:spPr>
           <a:xfrm>
             <a:off x="676656" y="5096256"/>
-            <a:ext cx="45720" cy="284988"/>
+            <a:ext cx="45720" cy="551688"/>
           </a:xfrm>
           <a:prstGeom prst="roundRect">
             <a:avLst>
@@ -15757,7 +15772,7 @@
         <p:spPr>
           <a:xfrm>
             <a:off x="877824" y="5087112"/>
-            <a:ext cx="10564063" cy="358140"/>
+            <a:ext cx="10564063" cy="624840"/>
           </a:xfrm>
           <a:prstGeom prst="rect">
             <a:avLst/>
@@ -15786,7 +15801,7 @@
                 </a:solidFill>
                 <a:latin typeface="Calibri"/>
               </a:rPr>
-              <a:t>The slide names the denominator the scheme pays for, the peak online hour, and says it aloud.</a:t>
+              <a:t>The slide names the denominator the scheme pays for, the peak online hour, and the presenter says it aloud.</a:t>
             </a:r>
           </a:p>
         </p:txBody>
@@ -17415,7 +17430,7 @@
                 </a:solidFill>
                 <a:latin typeface="Calibri"/>
               </a:rPr>
-              <a:t> [S], a staple asked everywhere in this programme's interview tags: present a recommendation to a non-technical stakeholder in two minutes, opening on that sentence.</a:t>
+              <a:t> [S], this programme's tag for a staple asked everywhere: present a recommendation to a non-technical stakeholder in two minutes, opening on that sentence.</a:t>
             </a:r>
           </a:p>
         </p:txBody>
@@ -20012,7 +20027,7 @@
                 </a:solidFill>
                 <a:latin typeface="Calibri"/>
               </a:rPr>
-              <a:t>A defence that sides with no one concedes each true part out loud and answers the rest from a line of evidence. Finance's row is the hardest: weekly requests fell four weeks running from 7 September, so the six-week rise of 1.8 percent hides a slide; the last three weeks answer it.</a:t>
+              <a:t>A defence that sides with no one concedes each true part out loud and answers the rest from a line of evidence. Finance's row is the hardest: weekly requests fell four weeks running from 7 September, so the six-week rise of 1.8 percent hides that decline; the last three weeks answer it.</a:t>
             </a:r>
           </a:p>
         </p:txBody>
@@ -30536,7 +30551,7 @@
                 </a:solidFill>
                 <a:latin typeface="Calibri"/>
               </a:rPr>
-              <a:t>Three turns of seven minutes, rotating, then eight minutes to rebuild the slide</a:t>
+              <a:t>The seats rotate through three turns of seven minutes, and then everyone has eight minutes to rebuild their slide</a:t>
             </a:r>
             <a:r>
               <a:rPr sz="1600" b="0" i="0">
@@ -35577,67 +35592,65 @@
       </p:pic>
       <p:sp>
         <p:nvSpPr>
-          <p:cNvPr id="10" name="Rounded Rectangle 9"/>
+          <p:cNvPr id="10" name="TextBox 9"/>
+          <p:cNvSpPr txBox="1"/>
+          <p:nvPr/>
+        </p:nvSpPr>
+        <p:spPr>
+          <a:xfrm>
+            <a:off x="530352" y="3908945"/>
+            <a:ext cx="11130991" cy="1048512"/>
+          </a:xfrm>
+          <a:prstGeom prst="rect">
+            <a:avLst/>
+          </a:prstGeom>
+          <a:noFill/>
+        </p:spPr>
+        <p:txBody>
+          <a:bodyPr wrap="square" anchor="t" lIns="0" rIns="0" tIns="0" bIns="0">
+            <a:spAutoFit/>
+          </a:bodyPr>
+          <a:lstStyle/>
+          <a:p>
+            <a:pPr>
+              <a:spcAft>
+                <a:spcPts val="800"/>
+              </a:spcAft>
+            </a:pPr>
+            <a:r>
+              <a:rPr sz="1600" b="1" i="0">
+                <a:solidFill>
+                  <a:srgbClr val="1A1440"/>
+                </a:solidFill>
+                <a:latin typeface="Calibri"/>
+              </a:rPr>
+              <a:t>Put the claim first and keep the caveat in sight.</a:t>
+            </a:r>
+            <a:r>
+              <a:rPr sz="1600" b="0" i="0">
+                <a:solidFill>
+                  <a:srgbClr val="1A1440"/>
+                </a:solidFill>
+                <a:latin typeface="Calibri"/>
+              </a:rPr>
+              <a:t> A slide that opens on its evidence makes the reader guess the point, and a caveat hidden in the appendix hands the person it affects a reason to call the slide dishonest.</a:t>
+            </a:r>
+          </a:p>
+        </p:txBody>
+      </p:sp>
+      <p:sp>
+        <p:nvSpPr>
+          <p:cNvPr id="11" name="Oval 10"/>
           <p:cNvSpPr/>
           <p:nvPr/>
         </p:nvSpPr>
         <p:spPr>
           <a:xfrm>
-            <a:off x="530352" y="3908945"/>
-            <a:ext cx="11130991" cy="1074420"/>
-          </a:xfrm>
-          <a:prstGeom prst="roundRect">
-            <a:avLst>
-              <a:gd name="adj" fmla="val 8000"/>
-            </a:avLst>
-          </a:prstGeom>
-          <a:solidFill>
-            <a:srgbClr val="F7F5FD"/>
-          </a:solidFill>
-          <a:ln w="9525">
-            <a:solidFill>
-              <a:srgbClr val="E4E1F1"/>
-            </a:solidFill>
-          </a:ln>
-          <a:effectLst/>
-        </p:spPr>
-        <p:style>
-          <a:lnRef idx="1">
-            <a:schemeClr val="accent1"/>
-          </a:lnRef>
-          <a:fillRef idx="3">
-            <a:schemeClr val="accent1"/>
-          </a:fillRef>
-          <a:effectRef idx="2">
-            <a:schemeClr val="accent1"/>
-          </a:effectRef>
-          <a:fontRef idx="minor">
-            <a:schemeClr val="lt1"/>
-          </a:fontRef>
-        </p:style>
-        <p:txBody>
-          <a:bodyPr rtlCol="0" anchor="ctr" wrap="square"/>
-          <a:lstStyle/>
-          <a:p>
-            <a:pPr algn="ctr"/>
-          </a:p>
-        </p:txBody>
-      </p:sp>
-      <p:sp>
-        <p:nvSpPr>
-          <p:cNvPr id="11" name="Rounded Rectangle 10"/>
-          <p:cNvSpPr/>
-          <p:nvPr/>
-        </p:nvSpPr>
-        <p:spPr>
-          <a:xfrm>
-            <a:off x="676656" y="4036961"/>
-            <a:ext cx="45720" cy="818388"/>
-          </a:xfrm>
-          <a:prstGeom prst="roundRect">
-            <a:avLst>
-              <a:gd name="adj" fmla="val 50000"/>
-            </a:avLst>
+            <a:off x="530352" y="6492240"/>
+            <a:ext cx="64008" cy="64008"/>
+          </a:xfrm>
+          <a:prstGeom prst="ellipse">
+            <a:avLst/>
           </a:prstGeom>
           <a:solidFill>
             <a:srgbClr val="5B3FD6"/>
@@ -35677,93 +35690,6 @@
         </p:nvSpPr>
         <p:spPr>
           <a:xfrm>
-            <a:off x="877824" y="4027817"/>
-            <a:ext cx="10564063" cy="891540"/>
-          </a:xfrm>
-          <a:prstGeom prst="rect">
-            <a:avLst/>
-          </a:prstGeom>
-          <a:noFill/>
-        </p:spPr>
-        <p:txBody>
-          <a:bodyPr wrap="square" anchor="ctr" lIns="0" rIns="0" tIns="0" bIns="0">
-            <a:spAutoFit/>
-          </a:bodyPr>
-          <a:lstStyle/>
-          <a:p>
-            <a:r>
-              <a:rPr sz="1500" b="1">
-                <a:solidFill>
-                  <a:srgbClr val="5B3FD6"/>
-                </a:solidFill>
-                <a:latin typeface="Calibri"/>
-              </a:rPr>
-              <a:t>The order is the point. </a:t>
-            </a:r>
-            <a:r>
-              <a:rPr sz="1500" b="0" i="0">
-                <a:solidFill>
-                  <a:srgbClr val="1A1440"/>
-                </a:solidFill>
-                <a:latin typeface="Calibri"/>
-              </a:rPr>
-              <a:t>Put the claim first: a slide that opens on its evidence makes the reader guess the point, and a caveat hidden in the appendix hands the person it affects a reason to call the slide dishonest.</a:t>
-            </a:r>
-          </a:p>
-        </p:txBody>
-      </p:sp>
-      <p:sp>
-        <p:nvSpPr>
-          <p:cNvPr id="13" name="Oval 12"/>
-          <p:cNvSpPr/>
-          <p:nvPr/>
-        </p:nvSpPr>
-        <p:spPr>
-          <a:xfrm>
-            <a:off x="530352" y="6492240"/>
-            <a:ext cx="64008" cy="64008"/>
-          </a:xfrm>
-          <a:prstGeom prst="ellipse">
-            <a:avLst/>
-          </a:prstGeom>
-          <a:solidFill>
-            <a:srgbClr val="5B3FD6"/>
-          </a:solidFill>
-          <a:ln>
-            <a:noFill/>
-          </a:ln>
-          <a:effectLst/>
-        </p:spPr>
-        <p:style>
-          <a:lnRef idx="1">
-            <a:schemeClr val="accent1"/>
-          </a:lnRef>
-          <a:fillRef idx="3">
-            <a:schemeClr val="accent1"/>
-          </a:fillRef>
-          <a:effectRef idx="2">
-            <a:schemeClr val="accent1"/>
-          </a:effectRef>
-          <a:fontRef idx="minor">
-            <a:schemeClr val="lt1"/>
-          </a:fontRef>
-        </p:style>
-        <p:txBody>
-          <a:bodyPr rtlCol="0" anchor="ctr" wrap="square"/>
-          <a:lstStyle/>
-          <a:p>
-            <a:pPr algn="ctr"/>
-          </a:p>
-        </p:txBody>
-      </p:sp>
-      <p:sp>
-        <p:nvSpPr>
-          <p:cNvPr id="14" name="TextBox 13"/>
-          <p:cNvSpPr txBox="1"/>
-          <p:nvPr/>
-        </p:nvSpPr>
-        <p:spPr>
-          <a:xfrm>
             <a:off x="640080" y="6437376"/>
             <a:ext cx="1286446" cy="152146"/>
           </a:xfrm>
@@ -35793,7 +35719,7 @@
       </p:sp>
       <p:sp>
         <p:nvSpPr>
-          <p:cNvPr id="15" name="Oval 14"/>
+          <p:cNvPr id="13" name="Oval 12"/>
           <p:cNvSpPr/>
           <p:nvPr/>
         </p:nvSpPr>
@@ -35837,7 +35763,7 @@
       </p:sp>
       <p:sp>
         <p:nvSpPr>
-          <p:cNvPr id="16" name="TextBox 15"/>
+          <p:cNvPr id="14" name="TextBox 13"/>
           <p:cNvSpPr txBox="1"/>
           <p:nvPr/>
         </p:nvSpPr>
@@ -35872,7 +35798,7 @@
       </p:sp>
       <p:sp>
         <p:nvSpPr>
-          <p:cNvPr id="17" name="Oval 16"/>
+          <p:cNvPr id="15" name="Oval 14"/>
           <p:cNvSpPr/>
           <p:nvPr/>
         </p:nvSpPr>
@@ -35916,7 +35842,7 @@
       </p:sp>
       <p:sp>
         <p:nvSpPr>
-          <p:cNvPr id="18" name="TextBox 17"/>
+          <p:cNvPr id="16" name="TextBox 15"/>
           <p:cNvSpPr txBox="1"/>
           <p:nvPr/>
         </p:nvSpPr>
@@ -35951,7 +35877,7 @@
       </p:sp>
       <p:sp>
         <p:nvSpPr>
-          <p:cNvPr id="19" name="TextBox 18"/>
+          <p:cNvPr id="17" name="TextBox 16"/>
           <p:cNvSpPr txBox="1"/>
           <p:nvPr/>
         </p:nvSpPr>

</xml_diff>